<commit_message>
Check the top 5% values on real data and soften the 3-minute wording
The 10-27 values match the envelope column of long-stats. Replace
"stayed in the 20s for 3 minutes" with "often rose into the 20s",
align the biceps rounding, and explain the terms in the notes.

Co-Authored-By: Claude Opus 5.5 <noreply@anthropic.com>
</commit_message>
<xml_diff>
--- a/docs/progress/slides/2026-10-29.pptx
+++ b/docs/progress/slides/2026-10-29.pptx
@@ -1161,7 +1161,7 @@
           <a:p/>
           <a:p>
             <a:r>
-              <a:t>前腕の伸筋と三角筋がよく働き、3 分間ずっと 20% 台（上位 5% の値）が続きました。屈筋・二頭筋・三頭筋は、ほぼ安静と同じです。</a:t>
+              <a:t>前腕の伸筋と三角筋がよく働き、3 分間を通して、たびたび 20% 台まで上がりました（上位 5% の値。3 分のうち、これを超えていたのは合わせて約 9 秒です）。屈筋・二頭筋・三頭筋は、ほぼ安静と同じです。</a:t>
             </a:r>
           </a:p>
           <a:p/>
@@ -1205,7 +1205,7 @@
           </a:p>
           <a:p>
             <a:r>
-              <a:t>S4 二頭筋 3 / 6 / 13 / 1</a:t>
+              <a:t>S4 二頭筋 2 / 6 / 12 / 1</a:t>
             </a:r>
           </a:p>
           <a:p>
@@ -15451,7 +15451,7 @@
         <p:spPr>
           <a:xfrm>
             <a:off x="2000250" y="2495550"/>
-            <a:ext cx="433388" cy="104775"/>
+            <a:ext cx="400050" cy="104775"/>
           </a:xfrm>
           <a:prstGeom prst="rect">
             <a:avLst/>
@@ -15541,7 +15541,7 @@
         </p:nvSpPr>
         <p:spPr>
           <a:xfrm>
-            <a:off x="2481262" y="2457450"/>
+            <a:off x="2447925" y="2457450"/>
             <a:ext cx="2000250" cy="171450"/>
           </a:xfrm>
           <a:prstGeom prst="rect">
@@ -15575,7 +15575,7 @@
                 <a:ea typeface="Meiryo"/>
                 <a:cs typeface="Meiryo"/>
               </a:rPr>
-              <a:t>13</a:t>
+              <a:t>12</a:t>
             </a:r>
           </a:p>
         </p:txBody>

</xml_diff>